<commit_message>
Fix inconsistent password normalization across auth flows
Centralize strip of spaces/hyphens/underscores/dots and enforce a single
8-character minimum matching the backend. Apply on login, register, join,
change password, delete account, and E2E unlock (with raw-password retry
for legacy envelopes). Update onboarding copy and pptx accordingly.

Co-authored-by: Cursor <cursoragent@cursor.com>
</commit_message>
<xml_diff>
--- a/docs/instrukcja-nowa-rodzina.pptx
+++ b/docs/instrukcja-nowa-rodzina.pptx
@@ -3290,7 +3290,7 @@
               </a:defRPr>
             </a:pPr>
             <a:r>
-              <a:t>Data urodzenia (jak w profilu) + hasło (min. 10 znaków).</a:t>
+              <a:t>Data urodzenia (jak w profilu) + hasło (min. 8 znaków).</a:t>
             </a:r>
           </a:p>
           <a:p>
@@ -3488,7 +3488,7 @@
               </a:defRPr>
             </a:pPr>
             <a:r>
-              <a:t>Hasło za krótkie → min. 10 znaków.</a:t>
+              <a:t>Hasło za krótkie → min. 8 znaków.</a:t>
             </a:r>
           </a:p>
           <a:p>
@@ -3761,7 +3761,7 @@
               </a:defRPr>
             </a:pPr>
             <a:r>
-              <a:t>Hasło: minimum 10 znaków.</a:t>
+              <a:t>Hasło: minimum 8 znaków.</a:t>
             </a:r>
           </a:p>
           <a:p>

</xml_diff>